<commit_message>
docs: unify accuracy on ledger.json source-of-truth; add recall-by-model chart; drop case-01 cherry-pick from README headline; align PPT chart to canonical 75.6/85.4/89.0
</commit_message>
<xml_diff>
--- a/docs/Agentic-DART-SANS-2026.pptx
+++ b/docs/Agentic-DART-SANS-2026.pptx
@@ -177,23 +177,21 @@
             <c:showLeaderLines val="0"/>
           </c:dLbls>
           <c:cat>
-            <c:multiLvlStrRef>
+            <c:strRef>
               <c:f>Sheet1!$A$2:$A$4</c:f>
-              <c:multiLvlStrCache>
+              <c:strCache>
                 <c:ptCount val="3"/>
-                <c:lvl>
-                  <c:pt idx="0">
-                    <c:v>Haiku</c:v>
-                  </c:pt>
-                  <c:pt idx="1">
-                    <c:v>Sonnet</c:v>
-                  </c:pt>
-                  <c:pt idx="2">
-                    <c:v>Opus</c:v>
-                  </c:pt>
-                </c:lvl>
-              </c:multiLvlStrCache>
-            </c:multiLvlStrRef>
+                <c:pt idx="0">
+                  <c:v>Haiku</c:v>
+                </c:pt>
+                <c:pt idx="1">
+                  <c:v>Sonnet</c:v>
+                </c:pt>
+                <c:pt idx="2">
+                  <c:v>Opus</c:v>
+                </c:pt>
+              </c:strCache>
+            </c:strRef>
           </c:cat>
           <c:val>
             <c:numRef>
@@ -202,13 +200,13 @@
                 <c:formatCode>General</c:formatCode>
                 <c:ptCount val="3"/>
                 <c:pt idx="0">
-                  <c:v>75.8</c:v>
+                  <c:v>75.6</c:v>
                 </c:pt>
                 <c:pt idx="1">
                   <c:v>85.4</c:v>
                 </c:pt>
                 <c:pt idx="2">
-                  <c:v>89.1</c:v>
+                  <c:v>89.0</c:v>
                 </c:pt>
               </c:numCache>
             </c:numRef>
@@ -260,23 +258,21 @@
             <c:showLeaderLines val="0"/>
           </c:dLbls>
           <c:cat>
-            <c:multiLvlStrRef>
+            <c:strRef>
               <c:f>Sheet1!$A$2:$A$4</c:f>
-              <c:multiLvlStrCache>
+              <c:strCache>
                 <c:ptCount val="3"/>
-                <c:lvl>
-                  <c:pt idx="0">
-                    <c:v>Haiku</c:v>
-                  </c:pt>
-                  <c:pt idx="1">
-                    <c:v>Sonnet</c:v>
-                  </c:pt>
-                  <c:pt idx="2">
-                    <c:v>Opus</c:v>
-                  </c:pt>
-                </c:lvl>
-              </c:multiLvlStrCache>
-            </c:multiLvlStrRef>
+                <c:pt idx="0">
+                  <c:v>Haiku</c:v>
+                </c:pt>
+                <c:pt idx="1">
+                  <c:v>Sonnet</c:v>
+                </c:pt>
+                <c:pt idx="2">
+                  <c:v>Opus</c:v>
+                </c:pt>
+              </c:strCache>
+            </c:strRef>
           </c:cat>
           <c:val>
             <c:numRef>
@@ -291,7 +287,7 @@
                   <c:v>43.3</c:v>
                 </c:pt>
                 <c:pt idx="2">
-                  <c:v>35</c:v>
+                  <c:v>35.0</c:v>
                 </c:pt>
               </c:numCache>
             </c:numRef>

</xml_diff>